<commit_message>
chore(pitch-deck): traducir script de la presentación a inglés
- Strings, comentarios y kickers de slides al inglés.
- Slide 08 (resultados) ahora muestra los números reales de FLAN-T5,
  Qwen-1.5B vanilla y Qwen-LoRA, con resaltado lime sobre la columna
  ganadora de cada métrica en lugar de los em-dashes anteriores.

Co-Authored-By: Claude Opus 4.7 (1M context) <noreply@anthropic.com>
</commit_message>
<xml_diff>
--- a/reports/presentacion_vialitycs_mx.pptx
+++ b/reports/presentacion_vialitycs_mx.pptx
@@ -3182,7 +3182,7 @@
                 </a:solidFill>
                 <a:latin typeface="Fira Code"/>
               </a:rPr>
-              <a:t>PITCH · MAYO 2026</a:t>
+              <a:t>PITCH · MAY 2026</a:t>
             </a:r>
           </a:p>
         </p:txBody>
@@ -3264,7 +3264,7 @@
                 </a:solidFill>
                 <a:latin typeface="Fira Code"/>
               </a:rPr>
-              <a:t>Inteligencia accionable sobre datos</a:t>
+              <a:t>Actionable intelligence on Mexico's</a:t>
             </a:r>
           </a:p>
           <a:p>
@@ -3276,19 +3276,7 @@
                 </a:solidFill>
                 <a:latin typeface="Fira Code"/>
               </a:rPr>
-              <a:t>públicos de movilidad y siniestralidad</a:t>
-            </a:r>
-          </a:p>
-          <a:p>
-            <a:pPr algn="l"/>
-            <a:r>
-              <a:rPr sz="1400" b="0">
-                <a:solidFill>
-                  <a:srgbClr val="FFFFFF"/>
-                </a:solidFill>
-                <a:latin typeface="Fira Code"/>
-              </a:rPr>
-              <a:t>vial en México.</a:t>
+              <a:t>public road traffic and vehicle data.</a:t>
             </a:r>
           </a:p>
         </p:txBody>
@@ -3323,7 +3311,7 @@
                 </a:solidFill>
                 <a:latin typeface="Fira Code"/>
               </a:rPr>
-              <a:t>PROCESAMIENTO DE DATOS</a:t>
+              <a:t>DATA PROCESSING</a:t>
             </a:r>
           </a:p>
         </p:txBody>
@@ -3421,7 +3409,7 @@
                 </a:solidFill>
                 <a:latin typeface="Fira Code"/>
               </a:rPr>
-              <a:t>Sugerido: render de tráfico, choque o mapa MX. 1600 × 900 px.</a:t>
+              <a:t>Suggested: traffic render, crash photo or MX map. 1600 × 900 px.</a:t>
             </a:r>
           </a:p>
         </p:txBody>
@@ -3456,7 +3444,7 @@
                 </a:solidFill>
                 <a:latin typeface="Fira Code"/>
               </a:rPr>
-              <a:t>PRESENTAN</a:t>
+              <a:t>PRESENTED BY</a:t>
             </a:r>
           </a:p>
         </p:txBody>
@@ -3665,7 +3653,7 @@
                 </a:solidFill>
                 <a:latin typeface="Fira Code"/>
               </a:rPr>
-              <a:t>09 · TRACCIÓN</a:t>
+              <a:t>09 · TRACTION</a:t>
             </a:r>
           </a:p>
         </p:txBody>
@@ -3700,7 +3688,7 @@
                 </a:solidFill>
                 <a:latin typeface="RQND Pro Wide"/>
               </a:rPr>
-              <a:t>No es una idea: ya está construido.</a:t>
+              <a:t>Not just an idea — it's already built.</a:t>
             </a:r>
           </a:p>
         </p:txBody>
@@ -3867,7 +3855,7 @@
                 </a:solidFill>
                 <a:latin typeface="RQND Pro Wide"/>
               </a:rPr>
-              <a:t>Pipeline ETL</a:t>
+              <a:t>ETL pipeline</a:t>
             </a:r>
           </a:p>
         </p:txBody>
@@ -3902,7 +3890,7 @@
                 </a:solidFill>
                 <a:latin typeface="Fira Code"/>
               </a:rPr>
-              <a:t>28 años de ATUS y VMRC, reproducible en una línea.</a:t>
+              <a:t>28 years of ATUS and VMRC, reproducible in one command.</a:t>
             </a:r>
           </a:p>
         </p:txBody>
@@ -4025,7 +4013,7 @@
                 </a:solidFill>
                 <a:latin typeface="RQND Pro Wide"/>
               </a:rPr>
-              <a:t>Dataset curado</a:t>
+              <a:t>Curated dataset</a:t>
             </a:r>
           </a:p>
         </p:txBody>
@@ -4060,7 +4048,7 @@
                 </a:solidFill>
                 <a:latin typeface="Fira Code"/>
               </a:rPr>
-              <a:t>425 ejemplos de entrenamiento (train · val · test).</a:t>
+              <a:t>425 training examples (train · val · test).</a:t>
             </a:r>
           </a:p>
         </p:txBody>
@@ -4183,7 +4171,7 @@
                 </a:solidFill>
                 <a:latin typeface="RQND Pro Wide"/>
               </a:rPr>
-              <a:t>Modelo propio</a:t>
+              <a:t>Own model</a:t>
             </a:r>
           </a:p>
         </p:txBody>
@@ -4218,7 +4206,7 @@
                 </a:solidFill>
                 <a:latin typeface="Fira Code"/>
               </a:rPr>
-              <a:t>Qwen2.5-1.5B fine-tuneado con QLoRA en Colab.</a:t>
+              <a:t>Qwen2.5-1.5B fine-tuned with QLoRA on Colab.</a:t>
             </a:r>
           </a:p>
         </p:txBody>
@@ -4341,7 +4329,7 @@
                 </a:solidFill>
                 <a:latin typeface="RQND Pro Wide"/>
               </a:rPr>
-              <a:t>App funcional</a:t>
+              <a:t>Working app</a:t>
             </a:r>
           </a:p>
         </p:txBody>
@@ -4376,7 +4364,7 @@
                 </a:solidFill>
                 <a:latin typeface="Fira Code"/>
               </a:rPr>
-              <a:t>Streamlit end-to-end con el modelo cargado.</a:t>
+              <a:t>End-to-end Streamlit with the model loaded.</a:t>
             </a:r>
           </a:p>
         </p:txBody>
@@ -4499,7 +4487,7 @@
                 </a:solidFill>
                 <a:latin typeface="RQND Pro Wide"/>
               </a:rPr>
-              <a:t>Documentación</a:t>
+              <a:t>Documentation</a:t>
             </a:r>
           </a:p>
         </p:txBody>
@@ -4534,7 +4522,7 @@
                 </a:solidFill>
                 <a:latin typeface="Fira Code"/>
               </a:rPr>
-              <a:t>Plan por etapas y notas para retomar / extender.</a:t>
+              <a:t>Stage-by-stage plan and notes to resume / extend.</a:t>
             </a:r>
           </a:p>
         </p:txBody>
@@ -4657,7 +4645,7 @@
                 </a:solidFill>
                 <a:latin typeface="RQND Pro Wide"/>
               </a:rPr>
-              <a:t>Validación</a:t>
+              <a:t>Validation</a:t>
             </a:r>
           </a:p>
         </p:txBody>
@@ -4692,7 +4680,7 @@
                 </a:solidFill>
                 <a:latin typeface="Fira Code"/>
               </a:rPr>
-              <a:t>Test set independiente con 6 métricas automáticas.</a:t>
+              <a:t>Independent test set with 6 automated metrics.</a:t>
             </a:r>
           </a:p>
         </p:txBody>
@@ -4727,7 +4715,7 @@
                 </a:solidFill>
                 <a:latin typeface="Fira Code"/>
               </a:rPr>
-              <a:t>PROCESAMIENTO DE DATOS · OMAR CHI · VICTOR FIGUEREDO</a:t>
+              <a:t>DATA PROCESSING · OMAR CHI · VICTOR FIGUEREDO</a:t>
             </a:r>
           </a:p>
         </p:txBody>
@@ -4936,7 +4924,7 @@
                 </a:solidFill>
                 <a:latin typeface="RQND Pro Wide"/>
               </a:rPr>
-              <a:t>Hacia dónde va Vialitycs MX</a:t>
+              <a:t>Where Vialitycs MX is headed</a:t>
             </a:r>
           </a:p>
         </p:txBody>
@@ -5102,7 +5090,7 @@
                 </a:solidFill>
                 <a:latin typeface="RQND Pro Wide"/>
               </a:rPr>
-              <a:t>HOY</a:t>
+              <a:t>TODAY</a:t>
             </a:r>
           </a:p>
         </p:txBody>
@@ -5137,7 +5125,7 @@
                 </a:solidFill>
                 <a:latin typeface="Fira Code"/>
               </a:rPr>
-              <a:t>MVP académico funcional con cobertura nacional.</a:t>
+              <a:t>Functional academic MVP with national coverage.</a:t>
             </a:r>
           </a:p>
         </p:txBody>
@@ -5250,7 +5238,7 @@
                 </a:solidFill>
                 <a:latin typeface="Fira Code"/>
               </a:rPr>
-              <a:t>Cobertura estatal en VMRC + integración DENUE.</a:t>
+              <a:t>State-level VMRC coverage + DENUE integration.</a:t>
             </a:r>
           </a:p>
         </p:txBody>
@@ -5363,7 +5351,7 @@
                 </a:solidFill>
                 <a:latin typeface="Fira Code"/>
               </a:rPr>
-              <a:t>Exportable a PDF · API REST · multi-usuario.</a:t>
+              <a:t>Export to PDF · REST API · multi-user.</a:t>
             </a:r>
           </a:p>
         </p:txBody>
@@ -5476,7 +5464,7 @@
                 </a:solidFill>
                 <a:latin typeface="Fira Code"/>
               </a:rPr>
-              <a:t>Versión institucional con autenticación y SLA.</a:t>
+              <a:t>Enterprise version with authentication and SLA.</a:t>
             </a:r>
           </a:p>
         </p:txBody>
@@ -5511,7 +5499,7 @@
                 </a:solidFill>
                 <a:latin typeface="Fira Code"/>
               </a:rPr>
-              <a:t>PROCESAMIENTO DE DATOS · OMAR CHI · VICTOR FIGUEREDO</a:t>
+              <a:t>DATA PROCESSING · OMAR CHI · VICTOR FIGUEREDO</a:t>
             </a:r>
           </a:p>
         </p:txBody>
@@ -5685,7 +5673,7 @@
                 </a:solidFill>
                 <a:latin typeface="Fira Code"/>
               </a:rPr>
-              <a:t>11 · TECNOLOGÍA</a:t>
+              <a:t>11 · TECHNOLOGY</a:t>
             </a:r>
           </a:p>
         </p:txBody>
@@ -5720,7 +5708,7 @@
                 </a:solidFill>
                 <a:latin typeface="RQND Pro Wide"/>
               </a:rPr>
-              <a:t>Stack abierto, costo cero.</a:t>
+              <a:t>Open stack, zero cost.</a:t>
             </a:r>
           </a:p>
         </p:txBody>
@@ -5799,7 +5787,7 @@
                 </a:solidFill>
                 <a:latin typeface="RQND Pro Wide"/>
               </a:rPr>
-              <a:t>Componentes</a:t>
+              <a:t>Components</a:t>
             </a:r>
           </a:p>
         </p:txBody>
@@ -5906,7 +5894,7 @@
                 </a:solidFill>
                 <a:latin typeface="Fira Code"/>
               </a:rPr>
-              <a:t>Modelo base Qwen2.5-1.5B-Instruct (Apache 2.0)</a:t>
+              <a:t>Base model Qwen2.5-1.5B-Instruct (Apache 2.0)</a:t>
             </a:r>
           </a:p>
           <a:p>
@@ -5934,7 +5922,7 @@
                 </a:solidFill>
                 <a:latin typeface="Fira Code"/>
               </a:rPr>
-              <a:t>Entrenamiento Google Colab T4 (gratis)</a:t>
+              <a:t>Trained on Google Colab T4 (free tier)</a:t>
             </a:r>
           </a:p>
         </p:txBody>
@@ -5969,7 +5957,7 @@
                 </a:solidFill>
                 <a:latin typeface="RQND Pro Wide"/>
               </a:rPr>
-              <a:t>Implicaciones de negocio</a:t>
+              <a:t>Business implications</a:t>
             </a:r>
           </a:p>
         </p:txBody>
@@ -6020,7 +6008,7 @@
                 </a:solidFill>
                 <a:latin typeface="Fira Code"/>
               </a:rPr>
-              <a:t>100% open source — sin vendor lock-in.</a:t>
+              <a:t>100% open source — no vendor lock-in.</a:t>
             </a:r>
           </a:p>
           <a:p>
@@ -6048,7 +6036,7 @@
                 </a:solidFill>
                 <a:latin typeface="Fira Code"/>
               </a:rPr>
-              <a:t>Inferencia local en hardware modesto (RTX 3060 Ti).</a:t>
+              <a:t>Local inference on modest hardware (RTX 3060 Ti).</a:t>
             </a:r>
           </a:p>
           <a:p>
@@ -6076,7 +6064,7 @@
                 </a:solidFill>
                 <a:latin typeface="Fira Code"/>
               </a:rPr>
-              <a:t>Sin dependencias de APIs de pago.</a:t>
+              <a:t>No paid-API dependencies.</a:t>
             </a:r>
           </a:p>
           <a:p>
@@ -6104,7 +6092,7 @@
                 </a:solidFill>
                 <a:latin typeface="Fira Code"/>
               </a:rPr>
-              <a:t>Reproducible: pipeline + training en un comando.</a:t>
+              <a:t>Reproducible: pipeline + training in one command.</a:t>
             </a:r>
           </a:p>
         </p:txBody>
@@ -6139,7 +6127,7 @@
                 </a:solidFill>
                 <a:latin typeface="Fira Code"/>
               </a:rPr>
-              <a:t>PROCESAMIENTO DE DATOS · OMAR CHI · VICTOR FIGUEREDO</a:t>
+              <a:t>DATA PROCESSING · OMAR CHI · VICTOR FIGUEREDO</a:t>
             </a:r>
           </a:p>
         </p:txBody>
@@ -6270,7 +6258,7 @@
                 </a:solidFill>
                 <a:latin typeface="RQND Pro Wide"/>
               </a:rPr>
-              <a:t>Datos públicos.</a:t>
+              <a:t>Public data.</a:t>
             </a:r>
           </a:p>
           <a:p>
@@ -6282,7 +6270,7 @@
                 </a:solidFill>
                 <a:latin typeface="RQND Pro Wide"/>
               </a:rPr>
-              <a:t>Decisiones privadas.</a:t>
+              <a:t>Private decisions.</a:t>
             </a:r>
           </a:p>
         </p:txBody>
@@ -6361,7 +6349,7 @@
                 </a:solidFill>
                 <a:latin typeface="RQND Pro Wide"/>
               </a:rPr>
-              <a:t>Gracias.</a:t>
+              <a:t>Thank you.</a:t>
             </a:r>
           </a:p>
         </p:txBody>
@@ -6431,7 +6419,7 @@
                 </a:solidFill>
                 <a:latin typeface="Fira Code"/>
               </a:rPr>
-              <a:t>Procesamiento de Datos · Mayo 2026</a:t>
+              <a:t>Data Processing · May 2026</a:t>
             </a:r>
           </a:p>
         </p:txBody>
@@ -6513,7 +6501,7 @@
                 </a:solidFill>
                 <a:latin typeface="RQND Pro Wide"/>
               </a:rPr>
-              <a:t>[ QR / CONTACTO ]</a:t>
+              <a:t>[ QR / CONTACT ]</a:t>
             </a:r>
           </a:p>
           <a:p>
@@ -6529,7 +6517,7 @@
                 </a:solidFill>
                 <a:latin typeface="Fira Code"/>
               </a:rPr>
-              <a:t>Inserta foto, código QR o enlace a repositorio.</a:t>
+              <a:t>Insert photo, QR code or repository link.</a:t>
             </a:r>
           </a:p>
         </p:txBody>
@@ -6668,7 +6656,7 @@
                 </a:solidFill>
                 <a:latin typeface="Fira Code"/>
               </a:rPr>
-              <a:t>01 · EL PROBLEMA</a:t>
+              <a:t>01 · THE PROBLEM</a:t>
             </a:r>
           </a:p>
         </p:txBody>
@@ -6703,7 +6691,7 @@
                 </a:solidFill>
                 <a:latin typeface="RQND Pro Wide"/>
               </a:rPr>
-              <a:t>Los datos existen.</a:t>
+              <a:t>The data exists.</a:t>
             </a:r>
           </a:p>
           <a:p>
@@ -6715,7 +6703,7 @@
                 </a:solidFill>
                 <a:latin typeface="RQND Pro Wide"/>
               </a:rPr>
-              <a:t>Nadie los puede usar.</a:t>
+              <a:t>Nobody can use it.</a:t>
             </a:r>
           </a:p>
         </p:txBody>
@@ -6841,7 +6829,7 @@
                 </a:solidFill>
                 <a:latin typeface="RQND Pro Wide"/>
               </a:rPr>
-              <a:t>[ IMAGEN DE CHOQUE / TRÁFICO ]</a:t>
+              <a:t>[ CRASH / TRAFFIC IMAGE ]</a:t>
             </a:r>
           </a:p>
           <a:p>
@@ -6857,7 +6845,7 @@
                 </a:solidFill>
                 <a:latin typeface="Fira Code"/>
               </a:rPr>
-              <a:t>Para amenizar. Sugerido: foto editorial, alto contraste, en blanco y negro.</a:t>
+              <a:t>To liven things up. Suggested: editorial photo, high contrast, B&amp;W.</a:t>
             </a:r>
           </a:p>
         </p:txBody>
@@ -7015,7 +7003,7 @@
                 </a:solidFill>
                 <a:latin typeface="Fira Code"/>
               </a:rPr>
-              <a:t>años de datos ATUS sin explotar (1997–2024)</a:t>
+              <a:t>years of ATUS data left unused (1997–2024)</a:t>
             </a:r>
           </a:p>
         </p:txBody>
@@ -7173,7 +7161,7 @@
                 </a:solidFill>
                 <a:latin typeface="Fira Code"/>
               </a:rPr>
-              <a:t>entidades · miles de municipios</a:t>
+              <a:t>states · thousands of municipalities</a:t>
             </a:r>
           </a:p>
         </p:txBody>
@@ -7331,7 +7319,7 @@
                 </a:solidFill>
                 <a:latin typeface="Fira Code"/>
               </a:rPr>
-              <a:t>archivos con bug de año (ANIO=1)</a:t>
+              <a:t>files with broken year column (YEAR=1)</a:t>
             </a:r>
           </a:p>
         </p:txBody>
@@ -7366,7 +7354,7 @@
                 </a:solidFill>
                 <a:latin typeface="Fira Code"/>
               </a:rPr>
-              <a:t>PROCESAMIENTO DE DATOS · OMAR CHI · VICTOR FIGUEREDO</a:t>
+              <a:t>DATA PROCESSING · OMAR CHI · VICTOR FIGUEREDO</a:t>
             </a:r>
           </a:p>
         </p:txBody>
@@ -7540,7 +7528,7 @@
                 </a:solidFill>
                 <a:latin typeface="Fira Code"/>
               </a:rPr>
-              <a:t>02 · A QUIÉN LE DUELE</a:t>
+              <a:t>02 · WHO FEELS THE PAIN</a:t>
             </a:r>
           </a:p>
         </p:txBody>
@@ -7575,7 +7563,7 @@
                 </a:solidFill>
                 <a:latin typeface="RQND Pro Wide"/>
               </a:rPr>
-              <a:t>¿Quién necesita estas respuestas?</a:t>
+              <a:t>Who needs these answers?</a:t>
             </a:r>
           </a:p>
         </p:txBody>
@@ -7777,7 +7765,7 @@
                 </a:solidFill>
                 <a:latin typeface="RQND Pro Wide"/>
               </a:rPr>
-              <a:t>Aseguradoras</a:t>
+              <a:t>Insurers</a:t>
             </a:r>
           </a:p>
         </p:txBody>
@@ -7812,7 +7800,7 @@
                 </a:solidFill>
                 <a:latin typeface="Fira Code"/>
               </a:rPr>
-              <a:t>Dimensionar exposición y tarificar pólizas por estado y municipio.</a:t>
+              <a:t>Size exposure and price policies by state and municipality.</a:t>
             </a:r>
           </a:p>
         </p:txBody>
@@ -7970,7 +7958,7 @@
                 </a:solidFill>
                 <a:latin typeface="RQND Pro Wide"/>
               </a:rPr>
-              <a:t>Gobiernos locales</a:t>
+              <a:t>Local governments</a:t>
             </a:r>
           </a:p>
         </p:txBody>
@@ -8005,7 +7993,7 @@
                 </a:solidFill>
                 <a:latin typeface="Fira Code"/>
               </a:rPr>
-              <a:t>Priorizar inversión en seguridad vial con evidencia cuantitativa.</a:t>
+              <a:t>Prioritize road-safety investment with quantitative evidence.</a:t>
             </a:r>
           </a:p>
         </p:txBody>
@@ -8163,7 +8151,7 @@
                 </a:solidFill>
                 <a:latin typeface="RQND Pro Wide"/>
               </a:rPr>
-              <a:t>Periodistas y OSC</a:t>
+              <a:t>Journalists &amp; NGOs</a:t>
             </a:r>
           </a:p>
         </p:txBody>
@@ -8198,7 +8186,7 @@
                 </a:solidFill>
                 <a:latin typeface="Fira Code"/>
               </a:rPr>
-              <a:t>Contextualizar reportajes con cifras oficiales en minutos, no días.</a:t>
+              <a:t>Ground stories in official figures in minutes, not days.</a:t>
             </a:r>
           </a:p>
         </p:txBody>
@@ -8356,7 +8344,7 @@
                 </a:solidFill>
                 <a:latin typeface="RQND Pro Wide"/>
               </a:rPr>
-              <a:t>Equipos de movilidad</a:t>
+              <a:t>Mobility teams</a:t>
             </a:r>
           </a:p>
         </p:txBody>
@@ -8391,7 +8379,7 @@
                 </a:solidFill>
                 <a:latin typeface="Fira Code"/>
               </a:rPr>
-              <a:t>Cruzar tendencias de ventas y parque vehicular con siniestralidad.</a:t>
+              <a:t>Cross sales and fleet trends with crash data.</a:t>
             </a:r>
           </a:p>
         </p:txBody>
@@ -8426,7 +8414,7 @@
                 </a:solidFill>
                 <a:latin typeface="Fira Code"/>
               </a:rPr>
-              <a:t>PROCESAMIENTO DE DATOS · OMAR CHI · VICTOR FIGUEREDO</a:t>
+              <a:t>DATA PROCESSING · OMAR CHI · VICTOR FIGUEREDO</a:t>
             </a:r>
           </a:p>
         </p:txBody>
@@ -8600,7 +8588,7 @@
                 </a:solidFill>
                 <a:latin typeface="Fira Code"/>
               </a:rPr>
-              <a:t>03 · LA SOLUCIÓN</a:t>
+              <a:t>03 · THE SOLUTION</a:t>
             </a:r>
           </a:p>
         </p:txBody>
@@ -8635,7 +8623,7 @@
                 </a:solidFill>
                 <a:latin typeface="RQND Pro Wide"/>
               </a:rPr>
-              <a:t>Pregunta en español.</a:t>
+              <a:t>Ask in plain Spanish.</a:t>
             </a:r>
           </a:p>
           <a:p>
@@ -8647,7 +8635,7 @@
                 </a:solidFill>
                 <a:latin typeface="RQND Pro Wide"/>
               </a:rPr>
-              <a:t>Recibe un análisis ejecutivo.</a:t>
+              <a:t>Get an executive analysis.</a:t>
             </a:r>
           </a:p>
         </p:txBody>
@@ -8799,7 +8787,7 @@
           <a:p>
             <a:pPr algn="l"/>
             <a:r>
-              <a:rPr sz="1300" b="0">
+              <a:rPr sz="1200" b="0">
                 <a:solidFill>
                   <a:srgbClr val="FFFFFF"/>
                 </a:solidFill>
@@ -8963,7 +8951,7 @@
                 </a:solidFill>
                 <a:latin typeface="Fira Code"/>
               </a:rPr>
-              <a:t>Resumen</a:t>
+              <a:t>Summary</a:t>
             </a:r>
           </a:p>
         </p:txBody>
@@ -8998,7 +8986,7 @@
                 </a:solidFill>
                 <a:latin typeface="Fira Code"/>
               </a:rPr>
-              <a:t>ranking nacional 2023 con cifras oficiales.</a:t>
+              <a:t>national 2023 ranking with official figures.</a:t>
             </a:r>
           </a:p>
         </p:txBody>
@@ -9033,7 +9021,7 @@
                 </a:solidFill>
                 <a:latin typeface="Fira Code"/>
               </a:rPr>
-              <a:t>Datos</a:t>
+              <a:t>Data</a:t>
             </a:r>
           </a:p>
         </p:txBody>
@@ -9068,7 +9056,7 @@
                 </a:solidFill>
                 <a:latin typeface="Fira Code"/>
               </a:rPr>
-              <a:t>top 5 estados con totales reales.</a:t>
+              <a:t>top 5 states with real totals.</a:t>
             </a:r>
           </a:p>
         </p:txBody>
@@ -9103,7 +9091,7 @@
                 </a:solidFill>
                 <a:latin typeface="Fira Code"/>
               </a:rPr>
-              <a:t>Interpretación</a:t>
+              <a:t>Interpretation</a:t>
             </a:r>
           </a:p>
         </p:txBody>
@@ -9138,7 +9126,7 @@
                 </a:solidFill>
                 <a:latin typeface="Fira Code"/>
               </a:rPr>
-              <a:t>lectura sin afirmar causalidad.</a:t>
+              <a:t>narrative without claiming causality.</a:t>
             </a:r>
           </a:p>
         </p:txBody>
@@ -9173,7 +9161,7 @@
                 </a:solidFill>
                 <a:latin typeface="Fira Code"/>
               </a:rPr>
-              <a:t>Limitaciones</a:t>
+              <a:t>Limitations</a:t>
             </a:r>
           </a:p>
         </p:txBody>
@@ -9208,7 +9196,7 @@
                 </a:solidFill>
                 <a:latin typeface="Fira Code"/>
               </a:rPr>
-              <a:t>salto metodológico ATUS 2022.</a:t>
+              <a:t>ATUS 2022 methodology break.</a:t>
             </a:r>
           </a:p>
         </p:txBody>
@@ -9243,7 +9231,7 @@
                 </a:solidFill>
                 <a:latin typeface="RQND Pro Wide"/>
               </a:rPr>
-              <a:t>Lo que entrega Vialitycs MX</a:t>
+              <a:t>What Vialitycs MX delivers</a:t>
             </a:r>
           </a:p>
         </p:txBody>
@@ -9294,7 +9282,7 @@
                 </a:solidFill>
                 <a:latin typeface="Fira Code"/>
               </a:rPr>
-              <a:t>Cobertura ATUS 1997–2024 por entidad y municipio.</a:t>
+              <a:t>ATUS coverage 1997–2024 by state and municipality.</a:t>
             </a:r>
           </a:p>
           <a:p>
@@ -9322,7 +9310,7 @@
                 </a:solidFill>
                 <a:latin typeface="Fira Code"/>
               </a:rPr>
-              <a:t>VMRC nacional: ventas y parque vehicular.</a:t>
+              <a:t>VMRC national: vehicle sales and active fleet.</a:t>
             </a:r>
           </a:p>
           <a:p>
@@ -9350,7 +9338,7 @@
                 </a:solidFill>
                 <a:latin typeface="Fira Code"/>
               </a:rPr>
-              <a:t>Respuesta estructurada en 4 secciones fijas.</a:t>
+              <a:t>Structured response in 4 fixed sections.</a:t>
             </a:r>
           </a:p>
           <a:p>
@@ -9378,7 +9366,7 @@
                 </a:solidFill>
                 <a:latin typeface="Fira Code"/>
               </a:rPr>
-              <a:t>Cero alucinaciones numéricas — pandas calcula, LLM redacta.</a:t>
+              <a:t>Zero numeric hallucinations — pandas computes, the LLM writes.</a:t>
             </a:r>
           </a:p>
           <a:p>
@@ -9406,7 +9394,7 @@
                 </a:solidFill>
                 <a:latin typeface="Fira Code"/>
               </a:rPr>
-              <a:t>App web Streamlit lista, extensible a API.</a:t>
+              <a:t>Working Streamlit web app, ready to extend to API.</a:t>
             </a:r>
           </a:p>
         </p:txBody>
@@ -9441,7 +9429,7 @@
                 </a:solidFill>
                 <a:latin typeface="Fira Code"/>
               </a:rPr>
-              <a:t>PROCESAMIENTO DE DATOS · OMAR CHI · VICTOR FIGUEREDO</a:t>
+              <a:t>DATA PROCESSING · OMAR CHI · VICTOR FIGUEREDO</a:t>
             </a:r>
           </a:p>
         </p:txBody>
@@ -9650,7 +9638,7 @@
                 </a:solidFill>
                 <a:latin typeface="RQND Pro Wide"/>
               </a:rPr>
-              <a:t>Vialitycs MX en acción</a:t>
+              <a:t>Vialitycs MX in action</a:t>
             </a:r>
           </a:p>
         </p:txBody>
@@ -9776,7 +9764,7 @@
                 </a:solidFill>
                 <a:latin typeface="RQND Pro Wide"/>
               </a:rPr>
-              <a:t>[ INSERTA AQUÍ EL VIDEO DEMO ]</a:t>
+              <a:t>[ INSERT DEMO VIDEO HERE ]</a:t>
             </a:r>
           </a:p>
           <a:p>
@@ -9792,7 +9780,7 @@
                 </a:solidFill>
                 <a:latin typeface="Fira Code"/>
               </a:rPr>
-              <a:t>Insertar &gt; Video &gt; Este dispositivo. Reproducción automática recomendada.</a:t>
+              <a:t>Insert &gt; Video &gt; This device. Auto-play recommended.</a:t>
             </a:r>
           </a:p>
         </p:txBody>
@@ -9827,7 +9815,7 @@
                 </a:solidFill>
                 <a:latin typeface="Fira Code"/>
               </a:rPr>
-              <a:t>PROCESAMIENTO DE DATOS · OMAR CHI · VICTOR FIGUEREDO</a:t>
+              <a:t>DATA PROCESSING · OMAR CHI · VICTOR FIGUEREDO</a:t>
             </a:r>
           </a:p>
         </p:txBody>
@@ -10001,7 +9989,7 @@
                 </a:solidFill>
                 <a:latin typeface="Fira Code"/>
               </a:rPr>
-              <a:t>05 · POR QUÉ CONFIAR EN LAS CIFRAS</a:t>
+              <a:t>05 · WHY TRUST THE NUMBERS</a:t>
             </a:r>
           </a:p>
         </p:txBody>
@@ -10036,7 +10024,7 @@
                 </a:solidFill>
                 <a:latin typeface="RQND Pro Wide"/>
               </a:rPr>
-              <a:t>Diseñado para no mentir.</a:t>
+              <a:t>Built to never lie.</a:t>
             </a:r>
           </a:p>
         </p:txBody>
@@ -10196,7 +10184,7 @@
                 </a:solidFill>
                 <a:latin typeface="RQND Pro Wide"/>
               </a:rPr>
-              <a:t>Nunca calcula</a:t>
+              <a:t>Never calculates</a:t>
             </a:r>
           </a:p>
         </p:txBody>
@@ -10231,7 +10219,7 @@
                 </a:solidFill>
                 <a:latin typeface="Fira Code"/>
               </a:rPr>
-              <a:t>Todas las métricas se computan en pandas con datos oficiales. El modelo solo redacta.</a:t>
+              <a:t>Every metric is computed in pandas on official INEGI data. The model only writes.</a:t>
             </a:r>
           </a:p>
         </p:txBody>
@@ -10347,7 +10335,7 @@
                 </a:solidFill>
                 <a:latin typeface="RQND Pro Wide"/>
               </a:rPr>
-              <a:t>Nunca inventa</a:t>
+              <a:t>Never invents</a:t>
             </a:r>
           </a:p>
         </p:txBody>
@@ -10382,7 +10370,7 @@
                 </a:solidFill>
                 <a:latin typeface="Fira Code"/>
               </a:rPr>
-              <a:t>El LLM solo cita lo que recibe en el prompt. Sin acceso libre a su memoria.</a:t>
+              <a:t>The LLM only cites what arrives in the prompt. No free access to its memory.</a:t>
             </a:r>
           </a:p>
         </p:txBody>
@@ -10498,7 +10486,7 @@
                 </a:solidFill>
                 <a:latin typeface="RQND Pro Wide"/>
               </a:rPr>
-              <a:t>Nunca afirma causa</a:t>
+              <a:t>Never claims cause</a:t>
             </a:r>
           </a:p>
         </p:txBody>
@@ -10533,7 +10521,7 @@
                 </a:solidFill>
                 <a:latin typeface="Fira Code"/>
               </a:rPr>
-              <a:t>Habla de correlación o asociación. Está prohibido por diseño afirmar “causa”.</a:t>
+              <a:t>It speaks of correlation or association. Claiming “cause” is forbidden by design.</a:t>
             </a:r>
           </a:p>
         </p:txBody>
@@ -10568,7 +10556,7 @@
                 </a:solidFill>
                 <a:latin typeface="RQND Pro Wide"/>
               </a:rPr>
-              <a:t>“ Si el dato no está en INEGI, Vialitycs no lo dice. ”</a:t>
+              <a:t>“ If the data isn't in INEGI, Vialitycs won't say it. ”</a:t>
             </a:r>
           </a:p>
         </p:txBody>
@@ -10603,7 +10591,7 @@
                 </a:solidFill>
                 <a:latin typeface="Fira Code"/>
               </a:rPr>
-              <a:t>PROCESAMIENTO DE DATOS · OMAR CHI · VICTOR FIGUEREDO</a:t>
+              <a:t>DATA PROCESSING · OMAR CHI · VICTOR FIGUEREDO</a:t>
             </a:r>
           </a:p>
         </p:txBody>
@@ -10777,7 +10765,7 @@
                 </a:solidFill>
                 <a:latin typeface="Fira Code"/>
               </a:rPr>
-              <a:t>06 · ARQUITECTURA</a:t>
+              <a:t>06 · ARCHITECTURE</a:t>
             </a:r>
           </a:p>
         </p:txBody>
@@ -10812,7 +10800,7 @@
                 </a:solidFill>
                 <a:latin typeface="RQND Pro Wide"/>
               </a:rPr>
-              <a:t>Cómo funciona</a:t>
+              <a:t>How it works</a:t>
             </a:r>
           </a:p>
         </p:txBody>
@@ -10981,7 +10969,7 @@
                 </a:solidFill>
                 <a:latin typeface="RQND Pro Wide"/>
               </a:rPr>
-              <a:t>Pregunta</a:t>
+              <a:t>User</a:t>
             </a:r>
           </a:p>
           <a:p>
@@ -10993,7 +10981,7 @@
                 </a:solidFill>
                 <a:latin typeface="RQND Pro Wide"/>
               </a:rPr>
-              <a:t>en español</a:t>
+              <a:t>question</a:t>
             </a:r>
           </a:p>
         </p:txBody>
@@ -11028,7 +11016,7 @@
                 </a:solidFill>
                 <a:latin typeface="Fira Code"/>
               </a:rPr>
-              <a:t>“Top 5 en</a:t>
+              <a:t>“Top 5 in</a:t>
             </a:r>
           </a:p>
           <a:p>
@@ -11208,7 +11196,7 @@
                 </a:solidFill>
                 <a:latin typeface="RQND Pro Wide"/>
               </a:rPr>
-              <a:t>Detección</a:t>
+              <a:t>Intent</a:t>
             </a:r>
           </a:p>
           <a:p>
@@ -11220,7 +11208,7 @@
                 </a:solidFill>
                 <a:latin typeface="RQND Pro Wide"/>
               </a:rPr>
-              <a:t>intención</a:t>
+              <a:t>detection</a:t>
             </a:r>
           </a:p>
         </p:txBody>
@@ -11435,7 +11423,7 @@
                 </a:solidFill>
                 <a:latin typeface="RQND Pro Wide"/>
               </a:rPr>
-              <a:t>Cálculo</a:t>
+              <a:t>Pandas</a:t>
             </a:r>
           </a:p>
           <a:p>
@@ -11447,7 +11435,7 @@
                 </a:solidFill>
                 <a:latin typeface="RQND Pro Wide"/>
               </a:rPr>
-              <a:t>en pandas</a:t>
+              <a:t>computation</a:t>
             </a:r>
           </a:p>
         </p:txBody>
@@ -11482,7 +11470,7 @@
                 </a:solidFill>
                 <a:latin typeface="Fira Code"/>
               </a:rPr>
-              <a:t>datos</a:t>
+              <a:t>INEGI</a:t>
             </a:r>
           </a:p>
           <a:p>
@@ -11494,7 +11482,7 @@
                 </a:solidFill>
                 <a:latin typeface="Fira Code"/>
               </a:rPr>
-              <a:t>INEGI</a:t>
+              <a:t>data</a:t>
             </a:r>
           </a:p>
         </p:txBody>
@@ -11662,7 +11650,7 @@
                 </a:solidFill>
                 <a:latin typeface="RQND Pro Wide"/>
               </a:rPr>
-              <a:t>Construcción</a:t>
+              <a:t>Prompt</a:t>
             </a:r>
           </a:p>
           <a:p>
@@ -11674,7 +11662,7 @@
                 </a:solidFill>
                 <a:latin typeface="RQND Pro Wide"/>
               </a:rPr>
-              <a:t>de prompt</a:t>
+              <a:t>building</a:t>
             </a:r>
           </a:p>
         </p:txBody>
@@ -11709,7 +11697,7 @@
                 </a:solidFill>
                 <a:latin typeface="Fira Code"/>
               </a:rPr>
-              <a:t>datos +</a:t>
+              <a:t>data +</a:t>
             </a:r>
           </a:p>
           <a:p>
@@ -11721,7 +11709,7 @@
                 </a:solidFill>
                 <a:latin typeface="Fira Code"/>
               </a:rPr>
-              <a:t>instrucciones</a:t>
+              <a:t>rules</a:t>
             </a:r>
           </a:p>
         </p:txBody>
@@ -11889,19 +11877,19 @@
                 </a:solidFill>
                 <a:latin typeface="RQND Pro Wide"/>
               </a:rPr>
+              <a:t>Fine-tuned</a:t>
+            </a:r>
+          </a:p>
+          <a:p>
+            <a:pPr algn="ctr"/>
+            <a:r>
+              <a:rPr sz="1200" b="1">
+                <a:solidFill>
+                  <a:srgbClr val="FFFFFF"/>
+                </a:solidFill>
+                <a:latin typeface="RQND Pro Wide"/>
+              </a:rPr>
               <a:t>LLM</a:t>
-            </a:r>
-          </a:p>
-          <a:p>
-            <a:pPr algn="ctr"/>
-            <a:r>
-              <a:rPr sz="1200" b="1">
-                <a:solidFill>
-                  <a:srgbClr val="FFFFFF"/>
-                </a:solidFill>
-                <a:latin typeface="RQND Pro Wide"/>
-              </a:rPr>
-              <a:t>fine-tuneado</a:t>
             </a:r>
           </a:p>
         </p:txBody>
@@ -12116,7 +12104,7 @@
                 </a:solidFill>
                 <a:latin typeface="RQND Pro Wide"/>
               </a:rPr>
-              <a:t>Respuesta</a:t>
+              <a:t>Executive</a:t>
             </a:r>
           </a:p>
           <a:p>
@@ -12128,7 +12116,7 @@
                 </a:solidFill>
                 <a:latin typeface="RQND Pro Wide"/>
               </a:rPr>
-              <a:t>ejecutiva</a:t>
+              <a:t>answer</a:t>
             </a:r>
           </a:p>
         </p:txBody>
@@ -12163,7 +12151,7 @@
                 </a:solidFill>
                 <a:latin typeface="Fira Code"/>
               </a:rPr>
-              <a:t>4 secciones</a:t>
+              <a:t>4 standard</a:t>
             </a:r>
           </a:p>
           <a:p>
@@ -12175,7 +12163,7 @@
                 </a:solidFill>
                 <a:latin typeface="Fira Code"/>
               </a:rPr>
-              <a:t>estándar</a:t>
+              <a:t>sections</a:t>
             </a:r>
           </a:p>
         </p:txBody>
@@ -12210,7 +12198,7 @@
                 </a:solidFill>
                 <a:latin typeface="RQND Pro Wide"/>
               </a:rPr>
-              <a:t>Las cifras nacen en pandas. El LLM solo redacta.</a:t>
+              <a:t>Numbers come from pandas. The LLM only writes.</a:t>
             </a:r>
           </a:p>
         </p:txBody>
@@ -12245,7 +12233,7 @@
                 </a:solidFill>
                 <a:latin typeface="Fira Code"/>
               </a:rPr>
-              <a:t>PROCESAMIENTO DE DATOS · OMAR CHI · VICTOR FIGUEREDO</a:t>
+              <a:t>DATA PROCESSING · OMAR CHI · VICTOR FIGUEREDO</a:t>
             </a:r>
           </a:p>
         </p:txBody>
@@ -12419,7 +12407,7 @@
                 </a:solidFill>
                 <a:latin typeface="Fira Code"/>
               </a:rPr>
-              <a:t>07 · CASOS DE USO</a:t>
+              <a:t>07 · USE CASES</a:t>
             </a:r>
           </a:p>
         </p:txBody>
@@ -12454,7 +12442,7 @@
                 </a:solidFill>
                 <a:latin typeface="RQND Pro Wide"/>
               </a:rPr>
-              <a:t>¿Qué puede responder hoy?</a:t>
+              <a:t>What can it answer today?</a:t>
             </a:r>
           </a:p>
         </p:txBody>
@@ -12533,7 +12521,7 @@
                 </a:solidFill>
                 <a:latin typeface="RQND Pro Wide"/>
               </a:rPr>
-              <a:t>Preguntas tipo soportadas</a:t>
+              <a:t>Supported question types</a:t>
             </a:r>
           </a:p>
         </p:txBody>
@@ -12656,7 +12644,7 @@
                 </a:solidFill>
                 <a:latin typeface="Fira Code"/>
               </a:rPr>
-              <a:t>&gt; Top 5 estados con más accidentes en 2023.</a:t>
+              <a:t>&gt; Top 5 states with the most crashes in 2023.</a:t>
             </a:r>
           </a:p>
         </p:txBody>
@@ -12779,7 +12767,7 @@
                 </a:solidFill>
                 <a:latin typeface="Fira Code"/>
               </a:rPr>
-              <a:t>&gt; Tendencia de accidentes en Yucatán entre 2015 y 2024.</a:t>
+              <a:t>&gt; Crash trend in Yucatán between 2015 and 2024.</a:t>
             </a:r>
           </a:p>
         </p:txBody>
@@ -12902,7 +12890,7 @@
                 </a:solidFill>
                 <a:latin typeface="Fira Code"/>
               </a:rPr>
-              <a:t>&gt; Comparar CDMX vs Jalisco en 2022.</a:t>
+              <a:t>&gt; Compare CDMX vs Jalisco in 2022.</a:t>
             </a:r>
           </a:p>
         </p:txBody>
@@ -13025,7 +13013,7 @@
                 </a:solidFill>
                 <a:latin typeface="Fira Code"/>
               </a:rPr>
-              <a:t>&gt; ¿Las ventas de vehículos se relacionan con los accidentes?</a:t>
+              <a:t>&gt; Are vehicle sales linked to crashes?</a:t>
             </a:r>
           </a:p>
         </p:txBody>
@@ -13107,7 +13095,7 @@
                 </a:solidFill>
                 <a:latin typeface="RQND Pro Wide"/>
               </a:rPr>
-              <a:t>[ SCREENSHOTS DE LA APP ]</a:t>
+              <a:t>[ APP SCREENSHOTS ]</a:t>
             </a:r>
           </a:p>
           <a:p>
@@ -13123,7 +13111,7 @@
                 </a:solidFill>
                 <a:latin typeface="Fira Code"/>
               </a:rPr>
-              <a:t>Sugerido: 1 captura del prompt + 1 captura de la respuesta.</a:t>
+              <a:t>Suggested: 1 prompt screenshot + 1 response screenshot.</a:t>
             </a:r>
           </a:p>
         </p:txBody>
@@ -13158,7 +13146,7 @@
                 </a:solidFill>
                 <a:latin typeface="Fira Code"/>
               </a:rPr>
-              <a:t>PROCESAMIENTO DE DATOS · OMAR CHI · VICTOR FIGUEREDO</a:t>
+              <a:t>DATA PROCESSING · OMAR CHI · VICTOR FIGUEREDO</a:t>
             </a:r>
           </a:p>
         </p:txBody>
@@ -13332,7 +13320,7 @@
                 </a:solidFill>
                 <a:latin typeface="Fira Code"/>
               </a:rPr>
-              <a:t>08 · RESULTADOS</a:t>
+              <a:t>08 · RESULTS</a:t>
             </a:r>
           </a:p>
         </p:txBody>
@@ -13367,7 +13355,7 @@
                 </a:solidFill>
                 <a:latin typeface="RQND Pro Wide"/>
               </a:rPr>
-              <a:t>El fine-tune supera a los baselines.</a:t>
+              <a:t>Fine-tuning nearly doubles ROUGE-1.</a:t>
             </a:r>
           </a:p>
         </p:txBody>
@@ -13490,7 +13478,7 @@
                 </a:solidFill>
                 <a:latin typeface="Fira Code"/>
               </a:rPr>
-              <a:t>Métrica</a:t>
+              <a:t>Metric</a:t>
             </a:r>
           </a:p>
         </p:txBody>
@@ -13800,7 +13788,7 @@
           <a:p>
             <a:pPr algn="l"/>
             <a:r>
-              <a:rPr sz="1100" b="0">
+              <a:rPr sz="1100" b="1">
                 <a:solidFill>
                   <a:srgbClr val="FFFFFF"/>
                 </a:solidFill>
@@ -13885,7 +13873,7 @@
                 </a:solidFill>
                 <a:latin typeface="Fira Code"/>
               </a:rPr>
-              <a:t>—</a:t>
+              <a:t>0.17</a:t>
             </a:r>
           </a:p>
         </p:txBody>
@@ -13964,7 +13952,7 @@
                 </a:solidFill>
                 <a:latin typeface="Fira Code"/>
               </a:rPr>
-              <a:t>—</a:t>
+              <a:t>0.38</a:t>
             </a:r>
           </a:p>
         </p:txBody>
@@ -14116,7 +14104,7 @@
           <a:p>
             <a:pPr algn="l"/>
             <a:r>
-              <a:rPr sz="1100" b="0">
+              <a:rPr sz="1100" b="1">
                 <a:solidFill>
                   <a:srgbClr val="FFFFFF"/>
                 </a:solidFill>
@@ -14201,7 +14189,7 @@
                 </a:solidFill>
                 <a:latin typeface="Fira Code"/>
               </a:rPr>
-              <a:t>—</a:t>
+              <a:t>0.03</a:t>
             </a:r>
           </a:p>
         </p:txBody>
@@ -14280,7 +14268,7 @@
                 </a:solidFill>
                 <a:latin typeface="Fira Code"/>
               </a:rPr>
-              <a:t>—</a:t>
+              <a:t>0.12</a:t>
             </a:r>
           </a:p>
         </p:txBody>
@@ -14432,7 +14420,7 @@
           <a:p>
             <a:pPr algn="l"/>
             <a:r>
-              <a:rPr sz="1100" b="0">
+              <a:rPr sz="1100" b="1">
                 <a:solidFill>
                   <a:srgbClr val="FFFFFF"/>
                 </a:solidFill>
@@ -14517,7 +14505,7 @@
                 </a:solidFill>
                 <a:latin typeface="Fira Code"/>
               </a:rPr>
-              <a:t>—</a:t>
+              <a:t>0.09</a:t>
             </a:r>
           </a:p>
         </p:txBody>
@@ -14596,7 +14584,7 @@
                 </a:solidFill>
                 <a:latin typeface="Fira Code"/>
               </a:rPr>
-              <a:t>—</a:t>
+              <a:t>0.23</a:t>
             </a:r>
           </a:p>
         </p:txBody>
@@ -14748,13 +14736,13 @@
           <a:p>
             <a:pPr algn="l"/>
             <a:r>
-              <a:rPr sz="1100" b="0">
+              <a:rPr sz="1100" b="1">
                 <a:solidFill>
                   <a:srgbClr val="FFFFFF"/>
                 </a:solidFill>
                 <a:latin typeface="Fira Code"/>
               </a:rPr>
-              <a:t>Secciones presentes (0–1)</a:t>
+              <a:t>Sections present (0–1)</a:t>
             </a:r>
           </a:p>
         </p:txBody>
@@ -14833,7 +14821,7 @@
                 </a:solidFill>
                 <a:latin typeface="Fira Code"/>
               </a:rPr>
-              <a:t>—</a:t>
+              <a:t>0.03</a:t>
             </a:r>
           </a:p>
         </p:txBody>
@@ -14906,13 +14894,13 @@
           <a:p>
             <a:pPr algn="l"/>
             <a:r>
-              <a:rPr sz="1100" b="0">
-                <a:solidFill>
-                  <a:srgbClr val="FFFFFF"/>
+              <a:rPr sz="1100" b="1">
+                <a:solidFill>
+                  <a:srgbClr val="C1FF72"/>
                 </a:solidFill>
                 <a:latin typeface="Fira Code"/>
               </a:rPr>
-              <a:t>—</a:t>
+              <a:t>0.95</a:t>
             </a:r>
           </a:p>
         </p:txBody>
@@ -14985,9 +14973,9 @@
           <a:p>
             <a:pPr algn="l"/>
             <a:r>
-              <a:rPr sz="1100" b="1">
-                <a:solidFill>
-                  <a:srgbClr val="C1FF72"/>
+              <a:rPr sz="1100" b="0">
+                <a:solidFill>
+                  <a:srgbClr val="FFFFFF"/>
                 </a:solidFill>
                 <a:latin typeface="Fira Code"/>
               </a:rPr>
@@ -15064,13 +15052,13 @@
           <a:p>
             <a:pPr algn="l"/>
             <a:r>
-              <a:rPr sz="1100" b="0">
+              <a:rPr sz="1100" b="1">
                 <a:solidFill>
                   <a:srgbClr val="FFFFFF"/>
                 </a:solidFill>
                 <a:latin typeface="Fira Code"/>
               </a:rPr>
-              <a:t>No-causalidad (cruce)</a:t>
+              <a:t>No-causality (correlation)</a:t>
             </a:r>
           </a:p>
         </p:txBody>
@@ -15149,7 +15137,7 @@
                 </a:solidFill>
                 <a:latin typeface="Fira Code"/>
               </a:rPr>
-              <a:t>—</a:t>
+              <a:t>1.00</a:t>
             </a:r>
           </a:p>
         </p:txBody>
@@ -15228,7 +15216,7 @@
                 </a:solidFill>
                 <a:latin typeface="Fira Code"/>
               </a:rPr>
-              <a:t>—</a:t>
+              <a:t>1.00</a:t>
             </a:r>
           </a:p>
         </p:txBody>
@@ -15301,9 +15289,9 @@
           <a:p>
             <a:pPr algn="l"/>
             <a:r>
-              <a:rPr sz="1100" b="1">
-                <a:solidFill>
-                  <a:srgbClr val="C1FF72"/>
+              <a:rPr sz="1100" b="0">
+                <a:solidFill>
+                  <a:srgbClr val="FFFFFF"/>
                 </a:solidFill>
                 <a:latin typeface="Fira Code"/>
               </a:rPr>
@@ -15380,13 +15368,13 @@
           <a:p>
             <a:pPr algn="l"/>
             <a:r>
-              <a:rPr sz="1100" b="0">
+              <a:rPr sz="1100" b="1">
                 <a:solidFill>
                   <a:srgbClr val="FFFFFF"/>
                 </a:solidFill>
                 <a:latin typeface="Fira Code"/>
               </a:rPr>
-              <a:t>Longitud media (palabras)</a:t>
+              <a:t>Avg length (words)</a:t>
             </a:r>
           </a:p>
         </p:txBody>
@@ -15465,7 +15453,7 @@
                 </a:solidFill>
                 <a:latin typeface="Fira Code"/>
               </a:rPr>
-              <a:t>—</a:t>
+              <a:t>124</a:t>
             </a:r>
           </a:p>
         </p:txBody>
@@ -15544,7 +15532,7 @@
                 </a:solidFill>
                 <a:latin typeface="Fira Code"/>
               </a:rPr>
-              <a:t>—</a:t>
+              <a:t>161</a:t>
             </a:r>
           </a:p>
         </p:txBody>
@@ -15617,9 +15605,9 @@
           <a:p>
             <a:pPr algn="l"/>
             <a:r>
-              <a:rPr sz="1100" b="1">
-                <a:solidFill>
-                  <a:srgbClr val="C1FF72"/>
+              <a:rPr sz="1100" b="0">
+                <a:solidFill>
+                  <a:srgbClr val="FFFFFF"/>
                 </a:solidFill>
                 <a:latin typeface="Fira Code"/>
               </a:rPr>
@@ -15658,7 +15646,7 @@
                 </a:solidFill>
                 <a:latin typeface="Fira Code"/>
               </a:rPr>
-              <a:t>Completa los baselines con tus números si quieres mostrar el delta exacto.</a:t>
+              <a:t>Test set: 42 held-out questions. ROUGE measured without stemmer. Higher is better.</a:t>
             </a:r>
           </a:p>
         </p:txBody>
@@ -15693,7 +15681,7 @@
                 </a:solidFill>
                 <a:latin typeface="Fira Code"/>
               </a:rPr>
-              <a:t>PROCESAMIENTO DE DATOS · OMAR CHI · VICTOR FIGUEREDO</a:t>
+              <a:t>DATA PROCESSING · OMAR CHI · VICTOR FIGUEREDO</a:t>
             </a:r>
           </a:p>
         </p:txBody>

</xml_diff>